<commit_message>
Reorder opening slide to receipts access and meals
</commit_message>
<xml_diff>
--- a/presentation/BM_Opening.pptx
+++ b/presentation/BM_Opening.pptx
@@ -3788,7 +3788,7 @@
               </a:defRPr>
             </a:pPr>
             <a:r>
-              <a:t>식사 신청 · 영수증 관리 · 현장 출입 신청, 세 가지 업무의 디지털 전환</a:t>
+              <a:t>영수증 관리 · 현장 출입 신청 · 식사 신청, 세 가지 업무의 디지털 전환</a:t>
             </a:r>
           </a:p>
         </p:txBody>
@@ -4136,7 +4136,7 @@
             <a:avLst/>
           </a:prstGeom>
           <a:solidFill>
-            <a:srgbClr val="008F99"/>
+            <a:srgbClr val="175EAF"/>
           </a:solidFill>
           <a:ln>
             <a:noFill/>
@@ -4237,7 +4237,7 @@
               </a:defRPr>
             </a:pPr>
             <a:r>
-              <a:t>식사 신청</a:t>
+              <a:t>법인카드 영수증 관리</a:t>
             </a:r>
           </a:p>
         </p:txBody>
@@ -4276,7 +4276,7 @@
               </a:defRPr>
             </a:pPr>
             <a:r>
-              <a:t>기존  개별 접수와 변경사항 재취합</a:t>
+              <a:t>기존  종이 제출·재입력·월말 재문의</a:t>
             </a:r>
           </a:p>
         </p:txBody>
@@ -4315,7 +4315,7 @@
               </a:defRPr>
             </a:pPr>
             <a:r>
-              <a:t>Cloud 웹 신청·내역 확인</a:t>
+              <a:t>Vision·Vertex AI + Cloud 저장</a:t>
             </a:r>
           </a:p>
         </p:txBody>
@@ -4397,7 +4397,7 @@
               </a:defRPr>
             </a:pPr>
             <a:r>
-              <a:t>신청은 한곳에서</a:t>
+              <a:t>사진을 업무 데이터로</a:t>
             </a:r>
           </a:p>
         </p:txBody>
@@ -4436,7 +4436,7 @@
               </a:defRPr>
             </a:pPr>
             <a:r>
-              <a:t>개별 접수·재취합 부담 완화</a:t>
+              <a:t>증빙·사용정보 연결, 확인 부담 완화</a:t>
             </a:r>
           </a:p>
         </p:txBody>
@@ -4499,7 +4499,7 @@
             <a:avLst/>
           </a:prstGeom>
           <a:solidFill>
-            <a:srgbClr val="175EAF"/>
+            <a:srgbClr val="008F99"/>
           </a:solidFill>
           <a:ln>
             <a:noFill/>
@@ -4600,7 +4600,7 @@
               </a:defRPr>
             </a:pPr>
             <a:r>
-              <a:t>법인카드 영수증 관리</a:t>
+              <a:t>현장 출입 신청</a:t>
             </a:r>
           </a:p>
         </p:txBody>
@@ -4639,7 +4639,7 @@
               </a:defRPr>
             </a:pPr>
             <a:r>
-              <a:t>기존  종이 제출·재입력·월말 재문의</a:t>
+              <a:t>기존  신청정보 반복 전달·누락 재확인</a:t>
             </a:r>
           </a:p>
         </p:txBody>
@@ -4678,7 +4678,7 @@
               </a:defRPr>
             </a:pPr>
             <a:r>
-              <a:t>Vision·Vertex AI + Cloud 저장</a:t>
+              <a:t>Cloud 기반 온라인 출입 신청</a:t>
             </a:r>
           </a:p>
         </p:txBody>
@@ -4760,7 +4760,7 @@
               </a:defRPr>
             </a:pPr>
             <a:r>
-              <a:t>사진을 업무 데이터로</a:t>
+              <a:t>신청 경로를 하나로</a:t>
             </a:r>
           </a:p>
         </p:txBody>
@@ -4799,7 +4799,7 @@
               </a:defRPr>
             </a:pPr>
             <a:r>
-              <a:t>증빙·사용정보 연결, 확인 부담 완화</a:t>
+              <a:t>전달 과정의 혼선·재확인 줄이기</a:t>
             </a:r>
           </a:p>
         </p:txBody>
@@ -4963,7 +4963,7 @@
               </a:defRPr>
             </a:pPr>
             <a:r>
-              <a:t>현장 출입 신청</a:t>
+              <a:t>식사 신청</a:t>
             </a:r>
           </a:p>
         </p:txBody>
@@ -5002,7 +5002,7 @@
               </a:defRPr>
             </a:pPr>
             <a:r>
-              <a:t>기존  신청정보 반복 전달·누락 재확인</a:t>
+              <a:t>기존  개별 접수와 변경사항 재취합</a:t>
             </a:r>
           </a:p>
         </p:txBody>
@@ -5041,7 +5041,7 @@
               </a:defRPr>
             </a:pPr>
             <a:r>
-              <a:t>Cloud 기반 온라인 출입 신청</a:t>
+              <a:t>Cloud 웹 신청·내역 확인</a:t>
             </a:r>
           </a:p>
         </p:txBody>
@@ -5123,7 +5123,7 @@
               </a:defRPr>
             </a:pPr>
             <a:r>
-              <a:t>신청 경로를 하나로</a:t>
+              <a:t>신청은 한곳에서</a:t>
             </a:r>
           </a:p>
         </p:txBody>
@@ -5162,7 +5162,7 @@
               </a:defRPr>
             </a:pPr>
             <a:r>
-              <a:t>전달 과정의 혼선·재확인 줄이기</a:t>
+              <a:t>개별 접수·재취합 부담 완화</a:t>
             </a:r>
           </a:p>
         </p:txBody>

</xml_diff>